<commit_message>
docs: add data-join diagram slide (slide 3) to roadmap deck
Co-Authored-By: Claude Opus 5.5 <noreply@anthropic.com>
</commit_message>
<xml_diff>
--- a/docs/status/project-roadmap.pptx
+++ b/docs/status/project-roadmap.pptx
@@ -7,9 +7,10 @@
   <p:sldIdLst>
     <p:sldId id="256" r:id="rId2"/>
     <p:sldId id="257" r:id="rId3"/>
+    <p:sldId id="258" r:id="rId4"/>
   </p:sldIdLst>
   <p:notesMasterIdLst>
-    <p:notesMasterId r:id="rId4"/>
+    <p:notesMasterId r:id="rId5"/>
   </p:notesMasterIdLst>
   <p:sldSz cx="12192000" cy="6858000"/>
   <p:notesSz cx="6858000" cy="12192000"/>
@@ -108,10 +109,11 @@
   <p:extLst>
     <p:ext uri="{521415D9-36F7-43E2-AB2F-B90AF26B5E84}">
       <p14:sectionLst xmlns:p14="http://schemas.microsoft.com/office/powerpoint/2010/main">
-        <p14:section name="Roadmap" id="{50756e69-4bff-4b4b-2b14-d06d9ab93939}">
+        <p14:section name="Roadmap" id="{e1aea346-a385-93e5-5255-80766a697603}">
           <p14:sldIdLst>
             <p14:sldId id="256"/>
             <p14:sldId id="257"/>
+            <p14:sldId id="258"/>
           </p14:sldIdLst>
         </p14:section>
       </p14:sectionLst>
@@ -648,6 +650,94 @@
 </p:notes>
 </file>
 
+<file path=ppt/notesSlides/notesSlide3.xml><?xml version="1.0" encoding="utf-8"?>
+<p:notes xmlns:a="http://schemas.openxmlformats.org/drawingml/2006/main" xmlns:r="http://schemas.openxmlformats.org/officeDocument/2006/relationships" xmlns:p="http://schemas.openxmlformats.org/presentationml/2006/main">
+  <p:cSld>
+    <p:spTree>
+      <p:nvGrpSpPr>
+        <p:cNvPr id="1" name=""/>
+        <p:cNvGrpSpPr/>
+        <p:nvPr/>
+      </p:nvGrpSpPr>
+      <p:grpSpPr>
+        <a:xfrm>
+          <a:off x="0" y="0"/>
+          <a:ext cx="0" cy="0"/>
+          <a:chOff x="0" y="0"/>
+          <a:chExt cx="0" cy="0"/>
+        </a:xfrm>
+      </p:grpSpPr>
+      <p:sp>
+        <p:nvSpPr>
+          <p:cNvPr id="2" name="Slide Image Placeholder 1"/>
+          <p:cNvSpPr>
+            <a:spLocks noGrp="1" noRot="1" noChangeAspect="1"/>
+          </p:cNvSpPr>
+          <p:nvPr>
+            <p:ph type="sldImg"/>
+          </p:nvPr>
+        </p:nvSpPr>
+        <p:spPr/>
+      </p:sp>
+      <p:sp>
+        <p:nvSpPr>
+          <p:cNvPr id="3" name="Notes Placeholder 2"/>
+          <p:cNvSpPr>
+            <a:spLocks noGrp="1"/>
+          </p:cNvSpPr>
+          <p:nvPr>
+            <p:ph type="body" idx="1"/>
+          </p:nvPr>
+        </p:nvSpPr>
+        <p:spPr/>
+        <p:txBody>
+          <a:bodyPr/>
+          <a:lstStyle/>
+          <a:p>
+            <a:r>
+              <a:rPr lang="en-US" dirty="0"/>
+              <a:t>The raw dataset is relational: aides.csv stores IDs that point to lookup tables. The selection script resolves those IDs into readable labels and writes one self-contained record per aid. Territories needed a correction: the source links three Picardie departments to Occitanie, so regions come from an official department-to-region table. Contacts are kept as IDs only for now.</a:t>
+            </a:r>
+            <a:endParaRPr lang="en-US" dirty="0"/>
+          </a:p>
+        </p:txBody>
+      </p:sp>
+      <p:sp>
+        <p:nvSpPr>
+          <p:cNvPr id="4" name="Slide Number Placeholder 3"/>
+          <p:cNvSpPr>
+            <a:spLocks noGrp="1"/>
+          </p:cNvSpPr>
+          <p:nvPr>
+            <p:ph type="sldNum" sz="quarter" idx="10"/>
+          </p:nvPr>
+        </p:nvSpPr>
+        <p:spPr/>
+        <p:txBody>
+          <a:bodyPr/>
+          <a:lstStyle/>
+          <a:p>
+            <a:fld id="{F7021451-1387-4CA6-816F-3879F97B5CBC}" type="slidenum">
+              <a:rPr lang="en-US"/>
+              <a:t>3</a:t>
+            </a:fld>
+            <a:endParaRPr lang="en-US"/>
+          </a:p>
+        </p:txBody>
+      </p:sp>
+    </p:spTree>
+    <p:extLst>
+      <p:ext uri="{BB962C8B-B14F-4D97-AF65-F5344CB8AC3E}">
+        <p14:creationId xmlns:p14="http://schemas.microsoft.com/office/powerpoint/2010/main" val="1024086991"/>
+      </p:ext>
+    </p:extLst>
+  </p:cSld>
+  <p:clrMapOvr>
+    <a:masterClrMapping/>
+  </p:clrMapOvr>
+</p:notes>
+</file>
+
 <file path=ppt/slideLayouts/slideLayout1.xml><?xml version="1.0" encoding="utf-8"?>
 <p:sldLayout xmlns:a="http://schemas.openxmlformats.org/drawingml/2006/main" xmlns:r="http://schemas.openxmlformats.org/officeDocument/2006/relationships" xmlns:p="http://schemas.openxmlformats.org/presentationml/2006/main" preserve="1">
   <p:cSld name="DEFAULT">
@@ -4930,6 +5020,1418 @@
                 </a:solidFill>
               </a:rPr>
               <a:t>Known limits: 47% of local aids have no region on file · 15 dead source links · test set half done · PR #1 awaiting Saouss's review</a:t>
+            </a:r>
+            <a:endParaRPr lang="en-US" sz="1000" dirty="0"/>
+          </a:p>
+        </p:txBody>
+      </p:sp>
+    </p:spTree>
+  </p:cSld>
+  <p:clrMapOvr>
+    <a:masterClrMapping/>
+  </p:clrMapOvr>
+</p:sld>
+</file>
+
+<file path=ppt/slides/slide3.xml><?xml version="1.0" encoding="utf-8"?>
+<p:sld xmlns:a="http://schemas.openxmlformats.org/drawingml/2006/main" xmlns:r="http://schemas.openxmlformats.org/officeDocument/2006/relationships" xmlns:p="http://schemas.openxmlformats.org/presentationml/2006/main">
+  <p:cSld name="Slide 3">
+    <p:spTree>
+      <p:nvGrpSpPr>
+        <p:cNvPr id="1" name=""/>
+        <p:cNvGrpSpPr/>
+        <p:nvPr/>
+      </p:nvGrpSpPr>
+      <p:grpSpPr>
+        <a:xfrm>
+          <a:off x="0" y="0"/>
+          <a:ext cx="0" cy="0"/>
+          <a:chOff x="0" y="0"/>
+          <a:chExt cx="0" cy="0"/>
+        </a:xfrm>
+      </p:grpSpPr>
+      <p:sp>
+        <p:nvSpPr>
+          <p:cNvPr id="2" name="Text 0"/>
+          <p:cNvSpPr/>
+          <p:nvPr>
+            <p:ph idx="100" type="title" hasCustomPrompt="1"/>
+          </p:nvPr>
+        </p:nvSpPr>
+        <p:spPr>
+          <a:xfrm>
+            <a:off x="548640" y="320040"/>
+            <a:ext cx="9144000" cy="685800"/>
+          </a:xfrm>
+          <a:prstGeom prst="rect">
+            <a:avLst/>
+          </a:prstGeom>
+          <a:noFill/>
+          <a:ln/>
+        </p:spPr>
+        <p:txBody>
+          <a:bodyPr wrap="square" lIns="0" tIns="0" rIns="0" bIns="0" rtlCol="0" anchor="ctr"/>
+          <a:lstStyle/>
+          <a:p>
+            <a:pPr algn="l" indent="0" marL="0">
+              <a:buNone/>
+            </a:pPr>
+            <a:r>
+              <a:rPr lang="en-US" sz="3000" b="1" dirty="0">
+                <a:solidFill>
+                  <a:schemeClr val="tx2"/>
+                </a:solidFill>
+              </a:rPr>
+              <a:t>How the 9 files fit together: one record per aid</a:t>
+            </a:r>
+            <a:endParaRPr lang="en-US" sz="3000" dirty="0"/>
+          </a:p>
+        </p:txBody>
+      </p:sp>
+      <p:sp>
+        <p:nvSpPr>
+          <p:cNvPr id="3" name="Subtitle 3"/>
+          <p:cNvSpPr txBox="1"/>
+          <p:nvPr/>
+        </p:nvSpPr>
+        <p:spPr>
+          <a:xfrm>
+            <a:off x="548640" y="1005840"/>
+            <a:ext cx="9144000" cy="320040"/>
+          </a:xfrm>
+          <a:prstGeom prst="rect">
+            <a:avLst/>
+          </a:prstGeom>
+          <a:noFill/>
+          <a:ln/>
+        </p:spPr>
+        <p:txBody>
+          <a:bodyPr wrap="square" lIns="0" tIns="0" rIns="0" bIns="0" rtlCol="0" anchor="ctr"/>
+          <a:lstStyle/>
+          <a:p>
+            <a:pPr indent="0" marL="0">
+              <a:buNone/>
+            </a:pPr>
+            <a:r>
+              <a:rPr lang="en-US" sz="1400" dirty="0">
+                <a:solidFill>
+                  <a:schemeClr val="accent6"/>
+                </a:solidFill>
+              </a:rPr>
+              <a:t>aides.csv points to lookup tables by ID; we join 5 of them into every aid</a:t>
+            </a:r>
+            <a:endParaRPr lang="en-US" sz="1400" dirty="0"/>
+          </a:p>
+        </p:txBody>
+      </p:sp>
+      <p:sp>
+        <p:nvSpPr>
+          <p:cNvPr id="4" name="Legend3 dot Joined"/>
+          <p:cNvSpPr/>
+          <p:nvPr/>
+        </p:nvSpPr>
+        <p:spPr>
+          <a:xfrm>
+            <a:off x="10012680" y="429768"/>
+            <a:ext cx="137160" cy="137160"/>
+          </a:xfrm>
+          <a:prstGeom prst="ellipse">
+            <a:avLst/>
+          </a:prstGeom>
+          <a:solidFill>
+            <a:schemeClr val="accent1"/>
+          </a:solidFill>
+          <a:ln w="12700">
+            <a:solidFill>
+              <a:schemeClr val="accent1"/>
+            </a:solidFill>
+            <a:prstDash val="solid"/>
+          </a:ln>
+        </p:spPr>
+      </p:sp>
+      <p:sp>
+        <p:nvSpPr>
+          <p:cNvPr id="5" name="Legend3 Joined"/>
+          <p:cNvSpPr txBox="1"/>
+          <p:nvPr/>
+        </p:nvSpPr>
+        <p:spPr>
+          <a:xfrm>
+            <a:off x="10222992" y="384048"/>
+            <a:ext cx="1463040" cy="228600"/>
+          </a:xfrm>
+          <a:prstGeom prst="rect">
+            <a:avLst/>
+          </a:prstGeom>
+          <a:noFill/>
+          <a:ln/>
+        </p:spPr>
+        <p:txBody>
+          <a:bodyPr wrap="square" lIns="0" tIns="0" rIns="0" bIns="0" rtlCol="0" anchor="ctr"/>
+          <a:lstStyle/>
+          <a:p>
+            <a:pPr indent="0" marL="0">
+              <a:buNone/>
+            </a:pPr>
+            <a:r>
+              <a:rPr lang="en-US" sz="1200" dirty="0">
+                <a:solidFill>
+                  <a:schemeClr val="tx1"/>
+                </a:solidFill>
+              </a:rPr>
+              <a:t>Joined</a:t>
+            </a:r>
+            <a:endParaRPr lang="en-US" sz="1200" dirty="0"/>
+          </a:p>
+        </p:txBody>
+      </p:sp>
+      <p:sp>
+        <p:nvSpPr>
+          <p:cNvPr id="6" name="Legend3 dot Partly joined"/>
+          <p:cNvSpPr/>
+          <p:nvPr/>
+        </p:nvSpPr>
+        <p:spPr>
+          <a:xfrm>
+            <a:off x="10012680" y="676656"/>
+            <a:ext cx="137160" cy="137160"/>
+          </a:xfrm>
+          <a:prstGeom prst="ellipse">
+            <a:avLst/>
+          </a:prstGeom>
+          <a:solidFill>
+            <a:schemeClr val="accent2"/>
+          </a:solidFill>
+          <a:ln w="12700">
+            <a:solidFill>
+              <a:schemeClr val="accent2"/>
+            </a:solidFill>
+            <a:prstDash val="solid"/>
+          </a:ln>
+        </p:spPr>
+      </p:sp>
+      <p:sp>
+        <p:nvSpPr>
+          <p:cNvPr id="7" name="Legend3 Partly joined"/>
+          <p:cNvSpPr txBox="1"/>
+          <p:nvPr/>
+        </p:nvSpPr>
+        <p:spPr>
+          <a:xfrm>
+            <a:off x="10222992" y="630936"/>
+            <a:ext cx="1463040" cy="228600"/>
+          </a:xfrm>
+          <a:prstGeom prst="rect">
+            <a:avLst/>
+          </a:prstGeom>
+          <a:noFill/>
+          <a:ln/>
+        </p:spPr>
+        <p:txBody>
+          <a:bodyPr wrap="square" lIns="0" tIns="0" rIns="0" bIns="0" rtlCol="0" anchor="ctr"/>
+          <a:lstStyle/>
+          <a:p>
+            <a:pPr indent="0" marL="0">
+              <a:buNone/>
+            </a:pPr>
+            <a:r>
+              <a:rPr lang="en-US" sz="1200" dirty="0">
+                <a:solidFill>
+                  <a:schemeClr val="tx1"/>
+                </a:solidFill>
+              </a:rPr>
+              <a:t>Partly joined</a:t>
+            </a:r>
+            <a:endParaRPr lang="en-US" sz="1200" dirty="0"/>
+          </a:p>
+        </p:txBody>
+      </p:sp>
+      <p:sp>
+        <p:nvSpPr>
+          <p:cNvPr id="8" name="Legend3 dot Not used"/>
+          <p:cNvSpPr/>
+          <p:nvPr/>
+        </p:nvSpPr>
+        <p:spPr>
+          <a:xfrm>
+            <a:off x="10012680" y="923544"/>
+            <a:ext cx="137160" cy="137160"/>
+          </a:xfrm>
+          <a:prstGeom prst="ellipse">
+            <a:avLst/>
+          </a:prstGeom>
+          <a:solidFill>
+            <a:schemeClr val="accent4"/>
+          </a:solidFill>
+          <a:ln w="12700">
+            <a:solidFill>
+              <a:schemeClr val="accent4"/>
+            </a:solidFill>
+            <a:prstDash val="solid"/>
+          </a:ln>
+        </p:spPr>
+      </p:sp>
+      <p:sp>
+        <p:nvSpPr>
+          <p:cNvPr id="9" name="Legend3 Not used"/>
+          <p:cNvSpPr txBox="1"/>
+          <p:nvPr/>
+        </p:nvSpPr>
+        <p:spPr>
+          <a:xfrm>
+            <a:off x="10222992" y="877824"/>
+            <a:ext cx="1463040" cy="228600"/>
+          </a:xfrm>
+          <a:prstGeom prst="rect">
+            <a:avLst/>
+          </a:prstGeom>
+          <a:noFill/>
+          <a:ln/>
+        </p:spPr>
+        <p:txBody>
+          <a:bodyPr wrap="square" lIns="0" tIns="0" rIns="0" bIns="0" rtlCol="0" anchor="ctr"/>
+          <a:lstStyle/>
+          <a:p>
+            <a:pPr indent="0" marL="0">
+              <a:buNone/>
+            </a:pPr>
+            <a:r>
+              <a:rPr lang="en-US" sz="1200" dirty="0">
+                <a:solidFill>
+                  <a:schemeClr val="tx1"/>
+                </a:solidFill>
+              </a:rPr>
+              <a:t>Not used</a:t>
+            </a:r>
+            <a:endParaRPr lang="en-US" sz="1200" dirty="0"/>
+          </a:p>
+        </p:txBody>
+      </p:sp>
+      <p:sp>
+        <p:nvSpPr>
+          <p:cNvPr id="10" name="Box natures"/>
+          <p:cNvSpPr/>
+          <p:nvPr/>
+        </p:nvSpPr>
+        <p:spPr>
+          <a:xfrm>
+            <a:off x="548640" y="1600200"/>
+            <a:ext cx="3383280" cy="960120"/>
+          </a:xfrm>
+          <a:prstGeom prst="roundRect">
+            <a:avLst>
+              <a:gd name="adj" fmla="val 9524"/>
+            </a:avLst>
+          </a:prstGeom>
+          <a:solidFill>
+            <a:schemeClr val="bg2"/>
+          </a:solidFill>
+          <a:ln w="22225">
+            <a:solidFill>
+              <a:schemeClr val="accent1"/>
+            </a:solidFill>
+            <a:prstDash val="solid"/>
+          </a:ln>
+        </p:spPr>
+      </p:sp>
+      <p:sp>
+        <p:nvSpPr>
+          <p:cNvPr id="11" name="Box head natures"/>
+          <p:cNvSpPr txBox="1"/>
+          <p:nvPr/>
+        </p:nvSpPr>
+        <p:spPr>
+          <a:xfrm>
+            <a:off x="731520" y="1691640"/>
+            <a:ext cx="3017520" cy="347472"/>
+          </a:xfrm>
+          <a:prstGeom prst="rect">
+            <a:avLst/>
+          </a:prstGeom>
+          <a:noFill/>
+          <a:ln/>
+        </p:spPr>
+        <p:txBody>
+          <a:bodyPr wrap="square" lIns="0" tIns="0" rIns="0" bIns="0" rtlCol="0" anchor="ctr"/>
+          <a:lstStyle/>
+          <a:p>
+            <a:pPr indent="0" marL="0">
+              <a:buNone/>
+            </a:pPr>
+            <a:r>
+              <a:rPr lang="en-US" sz="1500" b="1" dirty="0">
+                <a:solidFill>
+                  <a:schemeClr val="tx2"/>
+                </a:solidFill>
+              </a:rPr>
+              <a:t>natures.csv · 12 rows</a:t>
+            </a:r>
+            <a:endParaRPr lang="en-US" sz="1500" dirty="0"/>
+          </a:p>
+        </p:txBody>
+      </p:sp>
+      <p:sp>
+        <p:nvSpPr>
+          <p:cNvPr id="12" name="Box body natures"/>
+          <p:cNvSpPr txBox="1"/>
+          <p:nvPr/>
+        </p:nvSpPr>
+        <p:spPr>
+          <a:xfrm>
+            <a:off x="731520" y="2039112"/>
+            <a:ext cx="3017520" cy="457200"/>
+          </a:xfrm>
+          <a:prstGeom prst="rect">
+            <a:avLst/>
+          </a:prstGeom>
+          <a:noFill/>
+          <a:ln/>
+        </p:spPr>
+        <p:txBody>
+          <a:bodyPr wrap="square" lIns="0" tIns="0" rIns="0" bIns="0" rtlCol="0" anchor="t"/>
+          <a:lstStyle/>
+          <a:p>
+            <a:pPr indent="0" marL="0">
+              <a:buNone/>
+            </a:pPr>
+            <a:r>
+              <a:rPr lang="en-US" sz="1200" dirty="0">
+                <a:solidFill>
+                  <a:schemeClr val="tx1"/>
+                </a:solidFill>
+              </a:rPr>
+              <a:t>Aid type: grant, loan, tax relief… · 503 of 504 aids</a:t>
+            </a:r>
+            <a:endParaRPr lang="en-US" sz="1200" dirty="0"/>
+          </a:p>
+        </p:txBody>
+      </p:sp>
+      <p:sp>
+        <p:nvSpPr>
+          <p:cNvPr id="13" name="Link natures"/>
+          <p:cNvSpPr/>
+          <p:nvPr/>
+        </p:nvSpPr>
+        <p:spPr>
+          <a:xfrm>
+            <a:off x="3931920" y="2080260"/>
+            <a:ext cx="795528" cy="982980"/>
+          </a:xfrm>
+          <a:prstGeom prst="line">
+            <a:avLst/>
+          </a:prstGeom>
+          <a:noFill/>
+          <a:ln w="25400">
+            <a:solidFill>
+              <a:schemeClr val="accent1"/>
+            </a:solidFill>
+            <a:prstDash val="solid"/>
+          </a:ln>
+        </p:spPr>
+      </p:sp>
+      <p:sp>
+        <p:nvSpPr>
+          <p:cNvPr id="14" name="Box projets"/>
+          <p:cNvSpPr/>
+          <p:nvPr/>
+        </p:nvSpPr>
+        <p:spPr>
+          <a:xfrm>
+            <a:off x="548640" y="2743200"/>
+            <a:ext cx="3383280" cy="960120"/>
+          </a:xfrm>
+          <a:prstGeom prst="roundRect">
+            <a:avLst>
+              <a:gd name="adj" fmla="val 9524"/>
+            </a:avLst>
+          </a:prstGeom>
+          <a:solidFill>
+            <a:schemeClr val="bg2"/>
+          </a:solidFill>
+          <a:ln w="22225">
+            <a:solidFill>
+              <a:schemeClr val="accent1"/>
+            </a:solidFill>
+            <a:prstDash val="solid"/>
+          </a:ln>
+        </p:spPr>
+      </p:sp>
+      <p:sp>
+        <p:nvSpPr>
+          <p:cNvPr id="15" name="Box head projets"/>
+          <p:cNvSpPr txBox="1"/>
+          <p:nvPr/>
+        </p:nvSpPr>
+        <p:spPr>
+          <a:xfrm>
+            <a:off x="731520" y="2834640"/>
+            <a:ext cx="3017520" cy="347472"/>
+          </a:xfrm>
+          <a:prstGeom prst="rect">
+            <a:avLst/>
+          </a:prstGeom>
+          <a:noFill/>
+          <a:ln/>
+        </p:spPr>
+        <p:txBody>
+          <a:bodyPr wrap="square" lIns="0" tIns="0" rIns="0" bIns="0" rtlCol="0" anchor="ctr"/>
+          <a:lstStyle/>
+          <a:p>
+            <a:pPr indent="0" marL="0">
+              <a:buNone/>
+            </a:pPr>
+            <a:r>
+              <a:rPr lang="en-US" sz="1500" b="1" dirty="0">
+                <a:solidFill>
+                  <a:schemeClr val="tx2"/>
+                </a:solidFill>
+              </a:rPr>
+              <a:t>projets.csv · 101 rows</a:t>
+            </a:r>
+            <a:endParaRPr lang="en-US" sz="1500" dirty="0"/>
+          </a:p>
+        </p:txBody>
+      </p:sp>
+      <p:sp>
+        <p:nvSpPr>
+          <p:cNvPr id="16" name="Box body projets"/>
+          <p:cNvSpPr txBox="1"/>
+          <p:nvPr/>
+        </p:nvSpPr>
+        <p:spPr>
+          <a:xfrm>
+            <a:off x="731520" y="3182112"/>
+            <a:ext cx="3017520" cy="457200"/>
+          </a:xfrm>
+          <a:prstGeom prst="rect">
+            <a:avLst/>
+          </a:prstGeom>
+          <a:noFill/>
+          <a:ln/>
+        </p:spPr>
+        <p:txBody>
+          <a:bodyPr wrap="square" lIns="0" tIns="0" rIns="0" bIns="0" rtlCol="0" anchor="t"/>
+          <a:lstStyle/>
+          <a:p>
+            <a:pPr indent="0" marL="0">
+              <a:buNone/>
+            </a:pPr>
+            <a:r>
+              <a:rPr lang="en-US" sz="1200" dirty="0">
+                <a:solidFill>
+                  <a:schemeClr val="tx1"/>
+                </a:solidFill>
+              </a:rPr>
+              <a:t>Project themes, used for the green + innovation filter · 504 of 504</a:t>
+            </a:r>
+            <a:endParaRPr lang="en-US" sz="1200" dirty="0"/>
+          </a:p>
+        </p:txBody>
+      </p:sp>
+      <p:sp>
+        <p:nvSpPr>
+          <p:cNvPr id="17" name="Link projets"/>
+          <p:cNvSpPr/>
+          <p:nvPr/>
+        </p:nvSpPr>
+        <p:spPr>
+          <a:xfrm flipV="1">
+            <a:off x="3931920" y="3063240"/>
+            <a:ext cx="795528" cy="160020"/>
+          </a:xfrm>
+          <a:prstGeom prst="line">
+            <a:avLst/>
+          </a:prstGeom>
+          <a:noFill/>
+          <a:ln w="25400">
+            <a:solidFill>
+              <a:schemeClr val="accent1"/>
+            </a:solidFill>
+            <a:prstDash val="solid"/>
+          </a:ln>
+        </p:spPr>
+      </p:sp>
+      <p:sp>
+        <p:nvSpPr>
+          <p:cNvPr id="18" name="Box profils"/>
+          <p:cNvSpPr/>
+          <p:nvPr/>
+        </p:nvSpPr>
+        <p:spPr>
+          <a:xfrm>
+            <a:off x="548640" y="3886200"/>
+            <a:ext cx="3383280" cy="960120"/>
+          </a:xfrm>
+          <a:prstGeom prst="roundRect">
+            <a:avLst>
+              <a:gd name="adj" fmla="val 9524"/>
+            </a:avLst>
+          </a:prstGeom>
+          <a:solidFill>
+            <a:schemeClr val="bg2"/>
+          </a:solidFill>
+          <a:ln w="22225">
+            <a:solidFill>
+              <a:schemeClr val="accent1"/>
+            </a:solidFill>
+            <a:prstDash val="solid"/>
+          </a:ln>
+        </p:spPr>
+      </p:sp>
+      <p:sp>
+        <p:nvSpPr>
+          <p:cNvPr id="19" name="Box head profils"/>
+          <p:cNvSpPr txBox="1"/>
+          <p:nvPr/>
+        </p:nvSpPr>
+        <p:spPr>
+          <a:xfrm>
+            <a:off x="731520" y="3977640"/>
+            <a:ext cx="3017520" cy="347472"/>
+          </a:xfrm>
+          <a:prstGeom prst="rect">
+            <a:avLst/>
+          </a:prstGeom>
+          <a:noFill/>
+          <a:ln/>
+        </p:spPr>
+        <p:txBody>
+          <a:bodyPr wrap="square" lIns="0" tIns="0" rIns="0" bIns="0" rtlCol="0" anchor="ctr"/>
+          <a:lstStyle/>
+          <a:p>
+            <a:pPr indent="0" marL="0">
+              <a:buNone/>
+            </a:pPr>
+            <a:r>
+              <a:rPr lang="en-US" sz="1500" b="1" dirty="0">
+                <a:solidFill>
+                  <a:schemeClr val="tx2"/>
+                </a:solidFill>
+              </a:rPr>
+              <a:t>profils.csv · 17 rows</a:t>
+            </a:r>
+            <a:endParaRPr lang="en-US" sz="1500" dirty="0"/>
+          </a:p>
+        </p:txBody>
+      </p:sp>
+      <p:sp>
+        <p:nvSpPr>
+          <p:cNvPr id="20" name="Box body profils"/>
+          <p:cNvSpPr txBox="1"/>
+          <p:nvPr/>
+        </p:nvSpPr>
+        <p:spPr>
+          <a:xfrm>
+            <a:off x="731520" y="4325112"/>
+            <a:ext cx="3017520" cy="457200"/>
+          </a:xfrm>
+          <a:prstGeom prst="rect">
+            <a:avLst/>
+          </a:prstGeom>
+          <a:noFill/>
+          <a:ln/>
+        </p:spPr>
+        <p:txBody>
+          <a:bodyPr wrap="square" lIns="0" tIns="0" rIns="0" bIns="0" rtlCol="0" anchor="t"/>
+          <a:lstStyle/>
+          <a:p>
+            <a:pPr indent="0" marL="0">
+              <a:buNone/>
+            </a:pPr>
+            <a:r>
+              <a:rPr lang="en-US" sz="1200" dirty="0">
+                <a:solidFill>
+                  <a:schemeClr val="tx1"/>
+                </a:solidFill>
+              </a:rPr>
+              <a:t>Eligible business profiles (industry, crafts, retail…) · 504 of 504</a:t>
+            </a:r>
+            <a:endParaRPr lang="en-US" sz="1200" dirty="0"/>
+          </a:p>
+        </p:txBody>
+      </p:sp>
+      <p:sp>
+        <p:nvSpPr>
+          <p:cNvPr id="21" name="Link profils"/>
+          <p:cNvSpPr/>
+          <p:nvPr/>
+        </p:nvSpPr>
+        <p:spPr>
+          <a:xfrm flipV="1">
+            <a:off x="3931920" y="3063240"/>
+            <a:ext cx="795528" cy="1303020"/>
+          </a:xfrm>
+          <a:prstGeom prst="line">
+            <a:avLst/>
+          </a:prstGeom>
+          <a:noFill/>
+          <a:ln w="25400">
+            <a:solidFill>
+              <a:schemeClr val="accent1"/>
+            </a:solidFill>
+            <a:prstDash val="solid"/>
+          </a:ln>
+        </p:spPr>
+      </p:sp>
+      <p:sp>
+        <p:nvSpPr>
+          <p:cNvPr id="22" name="Box financeurs"/>
+          <p:cNvSpPr/>
+          <p:nvPr/>
+        </p:nvSpPr>
+        <p:spPr>
+          <a:xfrm>
+            <a:off x="8259775" y="1600200"/>
+            <a:ext cx="3383280" cy="960120"/>
+          </a:xfrm>
+          <a:prstGeom prst="roundRect">
+            <a:avLst>
+              <a:gd name="adj" fmla="val 9524"/>
+            </a:avLst>
+          </a:prstGeom>
+          <a:solidFill>
+            <a:schemeClr val="bg2"/>
+          </a:solidFill>
+          <a:ln w="22225">
+            <a:solidFill>
+              <a:schemeClr val="accent1"/>
+            </a:solidFill>
+            <a:prstDash val="solid"/>
+          </a:ln>
+        </p:spPr>
+      </p:sp>
+      <p:sp>
+        <p:nvSpPr>
+          <p:cNvPr id="23" name="Box head financeurs"/>
+          <p:cNvSpPr txBox="1"/>
+          <p:nvPr/>
+        </p:nvSpPr>
+        <p:spPr>
+          <a:xfrm>
+            <a:off x="8442655" y="1691640"/>
+            <a:ext cx="3017520" cy="347472"/>
+          </a:xfrm>
+          <a:prstGeom prst="rect">
+            <a:avLst/>
+          </a:prstGeom>
+          <a:noFill/>
+          <a:ln/>
+        </p:spPr>
+        <p:txBody>
+          <a:bodyPr wrap="square" lIns="0" tIns="0" rIns="0" bIns="0" rtlCol="0" anchor="ctr"/>
+          <a:lstStyle/>
+          <a:p>
+            <a:pPr indent="0" marL="0">
+              <a:buNone/>
+            </a:pPr>
+            <a:r>
+              <a:rPr lang="en-US" sz="1500" b="1" dirty="0">
+                <a:solidFill>
+                  <a:schemeClr val="tx2"/>
+                </a:solidFill>
+              </a:rPr>
+              <a:t>financeurs.csv · 1,427 rows</a:t>
+            </a:r>
+            <a:endParaRPr lang="en-US" sz="1500" dirty="0"/>
+          </a:p>
+        </p:txBody>
+      </p:sp>
+      <p:sp>
+        <p:nvSpPr>
+          <p:cNvPr id="24" name="Box body financeurs"/>
+          <p:cNvSpPr txBox="1"/>
+          <p:nvPr/>
+        </p:nvSpPr>
+        <p:spPr>
+          <a:xfrm>
+            <a:off x="8442655" y="2039112"/>
+            <a:ext cx="3017520" cy="457200"/>
+          </a:xfrm>
+          <a:prstGeom prst="rect">
+            <a:avLst/>
+          </a:prstGeom>
+          <a:noFill/>
+          <a:ln/>
+        </p:spPr>
+        <p:txBody>
+          <a:bodyPr wrap="square" lIns="0" tIns="0" rIns="0" bIns="0" rtlCol="0" anchor="t"/>
+          <a:lstStyle/>
+          <a:p>
+            <a:pPr indent="0" marL="0">
+              <a:buNone/>
+            </a:pPr>
+            <a:r>
+              <a:rPr lang="en-US" sz="1200" dirty="0">
+                <a:solidFill>
+                  <a:schemeClr val="tx1"/>
+                </a:solidFill>
+              </a:rPr>
+              <a:t>Funder names, and postcodes used to infer some regions · 504 of 504</a:t>
+            </a:r>
+            <a:endParaRPr lang="en-US" sz="1200" dirty="0"/>
+          </a:p>
+        </p:txBody>
+      </p:sp>
+      <p:sp>
+        <p:nvSpPr>
+          <p:cNvPr id="25" name="Link financeurs"/>
+          <p:cNvSpPr/>
+          <p:nvPr/>
+        </p:nvSpPr>
+        <p:spPr>
+          <a:xfrm flipV="1">
+            <a:off x="7470648" y="2080260"/>
+            <a:ext cx="789127" cy="982980"/>
+          </a:xfrm>
+          <a:prstGeom prst="line">
+            <a:avLst/>
+          </a:prstGeom>
+          <a:noFill/>
+          <a:ln w="25400">
+            <a:solidFill>
+              <a:schemeClr val="accent1"/>
+            </a:solidFill>
+            <a:prstDash val="solid"/>
+          </a:ln>
+        </p:spPr>
+      </p:sp>
+      <p:sp>
+        <p:nvSpPr>
+          <p:cNvPr id="26" name="Box territoires"/>
+          <p:cNvSpPr/>
+          <p:nvPr/>
+        </p:nvSpPr>
+        <p:spPr>
+          <a:xfrm>
+            <a:off x="8259775" y="2743200"/>
+            <a:ext cx="3383280" cy="960120"/>
+          </a:xfrm>
+          <a:prstGeom prst="roundRect">
+            <a:avLst>
+              <a:gd name="adj" fmla="val 9524"/>
+            </a:avLst>
+          </a:prstGeom>
+          <a:solidFill>
+            <a:schemeClr val="bg2"/>
+          </a:solidFill>
+          <a:ln w="22225">
+            <a:solidFill>
+              <a:schemeClr val="accent1"/>
+            </a:solidFill>
+            <a:prstDash val="solid"/>
+          </a:ln>
+        </p:spPr>
+      </p:sp>
+      <p:sp>
+        <p:nvSpPr>
+          <p:cNvPr id="27" name="Box head territoires"/>
+          <p:cNvSpPr txBox="1"/>
+          <p:nvPr/>
+        </p:nvSpPr>
+        <p:spPr>
+          <a:xfrm>
+            <a:off x="8442655" y="2834640"/>
+            <a:ext cx="3017520" cy="347472"/>
+          </a:xfrm>
+          <a:prstGeom prst="rect">
+            <a:avLst/>
+          </a:prstGeom>
+          <a:noFill/>
+          <a:ln/>
+        </p:spPr>
+        <p:txBody>
+          <a:bodyPr wrap="square" lIns="0" tIns="0" rIns="0" bIns="0" rtlCol="0" anchor="ctr"/>
+          <a:lstStyle/>
+          <a:p>
+            <a:pPr indent="0" marL="0">
+              <a:buNone/>
+            </a:pPr>
+            <a:r>
+              <a:rPr lang="en-US" sz="1500" b="1" dirty="0">
+                <a:solidFill>
+                  <a:schemeClr val="tx2"/>
+                </a:solidFill>
+              </a:rPr>
+              <a:t>territoires.csv · 39,348 rows</a:t>
+            </a:r>
+            <a:endParaRPr lang="en-US" sz="1500" dirty="0"/>
+          </a:p>
+        </p:txBody>
+      </p:sp>
+      <p:sp>
+        <p:nvSpPr>
+          <p:cNvPr id="28" name="Box body territoires"/>
+          <p:cNvSpPr txBox="1"/>
+          <p:nvPr/>
+        </p:nvSpPr>
+        <p:spPr>
+          <a:xfrm>
+            <a:off x="8442655" y="3182112"/>
+            <a:ext cx="3017520" cy="457200"/>
+          </a:xfrm>
+          <a:prstGeom prst="rect">
+            <a:avLst/>
+          </a:prstGeom>
+          <a:noFill/>
+          <a:ln/>
+        </p:spPr>
+        <p:txBody>
+          <a:bodyPr wrap="square" lIns="0" tIns="0" rIns="0" bIns="0" rtlCol="0" anchor="t"/>
+          <a:lstStyle/>
+          <a:p>
+            <a:pPr indent="0" marL="0">
+              <a:buNone/>
+            </a:pPr>
+            <a:r>
+              <a:rPr lang="en-US" sz="1200" dirty="0">
+                <a:solidFill>
+                  <a:schemeClr val="tx1"/>
+                </a:solidFill>
+              </a:rPr>
+              <a:t>Area → region, fixed with an official region table · 228 of 432 local aids</a:t>
+            </a:r>
+            <a:endParaRPr lang="en-US" sz="1200" dirty="0"/>
+          </a:p>
+        </p:txBody>
+      </p:sp>
+      <p:sp>
+        <p:nvSpPr>
+          <p:cNvPr id="29" name="Link territoires"/>
+          <p:cNvSpPr/>
+          <p:nvPr/>
+        </p:nvSpPr>
+        <p:spPr>
+          <a:xfrm>
+            <a:off x="7470648" y="3063240"/>
+            <a:ext cx="789127" cy="160020"/>
+          </a:xfrm>
+          <a:prstGeom prst="line">
+            <a:avLst/>
+          </a:prstGeom>
+          <a:noFill/>
+          <a:ln w="25400">
+            <a:solidFill>
+              <a:schemeClr val="accent1"/>
+            </a:solidFill>
+            <a:prstDash val="solid"/>
+          </a:ln>
+        </p:spPr>
+      </p:sp>
+      <p:sp>
+        <p:nvSpPr>
+          <p:cNvPr id="30" name="Box contacts"/>
+          <p:cNvSpPr/>
+          <p:nvPr/>
+        </p:nvSpPr>
+        <p:spPr>
+          <a:xfrm>
+            <a:off x="8259775" y="3886200"/>
+            <a:ext cx="3383280" cy="960120"/>
+          </a:xfrm>
+          <a:prstGeom prst="roundRect">
+            <a:avLst>
+              <a:gd name="adj" fmla="val 9524"/>
+            </a:avLst>
+          </a:prstGeom>
+          <a:solidFill>
+            <a:schemeClr val="bg2"/>
+          </a:solidFill>
+          <a:ln w="22225">
+            <a:solidFill>
+              <a:schemeClr val="accent2"/>
+            </a:solidFill>
+            <a:prstDash val="solid"/>
+          </a:ln>
+        </p:spPr>
+      </p:sp>
+      <p:sp>
+        <p:nvSpPr>
+          <p:cNvPr id="31" name="Box head contacts"/>
+          <p:cNvSpPr txBox="1"/>
+          <p:nvPr/>
+        </p:nvSpPr>
+        <p:spPr>
+          <a:xfrm>
+            <a:off x="8442655" y="3977640"/>
+            <a:ext cx="3017520" cy="347472"/>
+          </a:xfrm>
+          <a:prstGeom prst="rect">
+            <a:avLst/>
+          </a:prstGeom>
+          <a:noFill/>
+          <a:ln/>
+        </p:spPr>
+        <p:txBody>
+          <a:bodyPr wrap="square" lIns="0" tIns="0" rIns="0" bIns="0" rtlCol="0" anchor="ctr"/>
+          <a:lstStyle/>
+          <a:p>
+            <a:pPr indent="0" marL="0">
+              <a:buNone/>
+            </a:pPr>
+            <a:r>
+              <a:rPr lang="en-US" sz="1500" b="1" dirty="0">
+                <a:solidFill>
+                  <a:schemeClr val="tx2"/>
+                </a:solidFill>
+              </a:rPr>
+              <a:t>contacts.csv · 7,925 rows</a:t>
+            </a:r>
+            <a:endParaRPr lang="en-US" sz="1500" dirty="0"/>
+          </a:p>
+        </p:txBody>
+      </p:sp>
+      <p:sp>
+        <p:nvSpPr>
+          <p:cNvPr id="32" name="Box body contacts"/>
+          <p:cNvSpPr txBox="1"/>
+          <p:nvPr/>
+        </p:nvSpPr>
+        <p:spPr>
+          <a:xfrm>
+            <a:off x="8442655" y="4325112"/>
+            <a:ext cx="3017520" cy="457200"/>
+          </a:xfrm>
+          <a:prstGeom prst="rect">
+            <a:avLst/>
+          </a:prstGeom>
+          <a:noFill/>
+          <a:ln/>
+        </p:spPr>
+        <p:txBody>
+          <a:bodyPr wrap="square" lIns="0" tIns="0" rIns="0" bIns="0" rtlCol="0" anchor="t"/>
+          <a:lstStyle/>
+          <a:p>
+            <a:pPr indent="0" marL="0">
+              <a:buNone/>
+            </a:pPr>
+            <a:r>
+              <a:rPr lang="en-US" sz="1200" dirty="0">
+                <a:solidFill>
+                  <a:schemeClr val="tx1"/>
+                </a:solidFill>
+              </a:rPr>
+              <a:t>Contact IDs kept, details not joined yet (Phase 2 if needed) · 503 of 504</a:t>
+            </a:r>
+            <a:endParaRPr lang="en-US" sz="1200" dirty="0"/>
+          </a:p>
+        </p:txBody>
+      </p:sp>
+      <p:sp>
+        <p:nvSpPr>
+          <p:cNvPr id="33" name="Link contacts"/>
+          <p:cNvSpPr/>
+          <p:nvPr/>
+        </p:nvSpPr>
+        <p:spPr>
+          <a:xfrm>
+            <a:off x="7470648" y="3063240"/>
+            <a:ext cx="789127" cy="1303020"/>
+          </a:xfrm>
+          <a:prstGeom prst="line">
+            <a:avLst/>
+          </a:prstGeom>
+          <a:noFill/>
+          <a:ln w="25400">
+            <a:solidFill>
+              <a:schemeClr val="accent2"/>
+            </a:solidFill>
+            <a:prstDash val="solid"/>
+          </a:ln>
+        </p:spPr>
+      </p:sp>
+      <p:sp>
+        <p:nvSpPr>
+          <p:cNvPr id="34" name="Hub"/>
+          <p:cNvSpPr/>
+          <p:nvPr/>
+        </p:nvSpPr>
+        <p:spPr>
+          <a:xfrm>
+            <a:off x="4727448" y="2377440"/>
+            <a:ext cx="2743200" cy="1371600"/>
+          </a:xfrm>
+          <a:prstGeom prst="roundRect">
+            <a:avLst>
+              <a:gd name="adj" fmla="val 8000"/>
+            </a:avLst>
+          </a:prstGeom>
+          <a:solidFill>
+            <a:schemeClr val="tx2"/>
+          </a:solidFill>
+          <a:ln w="12700">
+            <a:solidFill>
+              <a:schemeClr val="tx2"/>
+            </a:solidFill>
+            <a:prstDash val="solid"/>
+          </a:ln>
+        </p:spPr>
+      </p:sp>
+      <p:sp>
+        <p:nvSpPr>
+          <p:cNvPr id="35" name="Hub text"/>
+          <p:cNvSpPr txBox="1"/>
+          <p:nvPr/>
+        </p:nvSpPr>
+        <p:spPr>
+          <a:xfrm>
+            <a:off x="4727448" y="2377440"/>
+            <a:ext cx="2743200" cy="1371600"/>
+          </a:xfrm>
+          <a:prstGeom prst="rect">
+            <a:avLst/>
+          </a:prstGeom>
+          <a:noFill/>
+          <a:ln/>
+        </p:spPr>
+        <p:txBody>
+          <a:bodyPr wrap="square" lIns="0" tIns="0" rIns="0" bIns="0" rtlCol="0" anchor="ctr"/>
+          <a:lstStyle/>
+          <a:p>
+            <a:pPr algn="ctr" indent="0" marL="0">
+              <a:buNone/>
+            </a:pPr>
+            <a:r>
+              <a:rPr lang="en-US" sz="2000" b="1" dirty="0">
+                <a:solidFill>
+                  <a:schemeClr val="bg1"/>
+                </a:solidFill>
+              </a:rPr>
+              <a:t>aides.csv</a:t>
+            </a:r>
+            <a:endParaRPr lang="en-US" sz="2000" dirty="0"/>
+          </a:p>
+          <a:p>
+            <a:pPr algn="ctr" indent="0" marL="0">
+              <a:buNone/>
+            </a:pPr>
+            <a:r>
+              <a:rPr lang="en-US" sz="1300" dirty="0">
+                <a:solidFill>
+                  <a:schemeClr val="bg1"/>
+                </a:solidFill>
+              </a:rPr>
+              <a:t>2,442 aids, filtered to 504</a:t>
+            </a:r>
+            <a:endParaRPr lang="en-US" sz="2000" dirty="0"/>
+          </a:p>
+        </p:txBody>
+      </p:sp>
+      <p:sp>
+        <p:nvSpPr>
+          <p:cNvPr id="36" name="Output arrow"/>
+          <p:cNvSpPr/>
+          <p:nvPr/>
+        </p:nvSpPr>
+        <p:spPr>
+          <a:xfrm>
+            <a:off x="6099048" y="3749040"/>
+            <a:ext cx="0" cy="457200"/>
+          </a:xfrm>
+          <a:prstGeom prst="line">
+            <a:avLst/>
+          </a:prstGeom>
+          <a:noFill/>
+          <a:ln w="31750">
+            <a:solidFill>
+              <a:schemeClr val="accent1"/>
+            </a:solidFill>
+            <a:prstDash val="solid"/>
+            <a:tailEnd type="triangle"/>
+          </a:ln>
+        </p:spPr>
+      </p:sp>
+      <p:sp>
+        <p:nvSpPr>
+          <p:cNvPr id="37" name="Output"/>
+          <p:cNvSpPr/>
+          <p:nvPr/>
+        </p:nvSpPr>
+        <p:spPr>
+          <a:xfrm>
+            <a:off x="4544568" y="4206240"/>
+            <a:ext cx="3108960" cy="868680"/>
+          </a:xfrm>
+          <a:prstGeom prst="roundRect">
+            <a:avLst>
+              <a:gd name="adj" fmla="val 12632"/>
+            </a:avLst>
+          </a:prstGeom>
+          <a:solidFill>
+            <a:schemeClr val="accent1"/>
+          </a:solidFill>
+          <a:ln w="12700">
+            <a:solidFill>
+              <a:schemeClr val="accent1"/>
+            </a:solidFill>
+            <a:prstDash val="solid"/>
+          </a:ln>
+        </p:spPr>
+      </p:sp>
+      <p:sp>
+        <p:nvSpPr>
+          <p:cNvPr id="38" name="Output text"/>
+          <p:cNvSpPr txBox="1"/>
+          <p:nvPr/>
+        </p:nvSpPr>
+        <p:spPr>
+          <a:xfrm>
+            <a:off x="4544568" y="4206240"/>
+            <a:ext cx="3108960" cy="868680"/>
+          </a:xfrm>
+          <a:prstGeom prst="rect">
+            <a:avLst/>
+          </a:prstGeom>
+          <a:noFill/>
+          <a:ln/>
+        </p:spPr>
+        <p:txBody>
+          <a:bodyPr wrap="square" lIns="0" tIns="0" rIns="0" bIns="0" rtlCol="0" anchor="ctr"/>
+          <a:lstStyle/>
+          <a:p>
+            <a:pPr algn="ctr" indent="0" marL="0">
+              <a:buNone/>
+            </a:pPr>
+            <a:r>
+              <a:rPr lang="en-US" sz="1700" b="1" dirty="0">
+                <a:solidFill>
+                  <a:schemeClr val="bg1"/>
+                </a:solidFill>
+              </a:rPr>
+              <a:t>aids.jsonl</a:t>
+            </a:r>
+            <a:endParaRPr lang="en-US" sz="1700" dirty="0"/>
+          </a:p>
+          <a:p>
+            <a:pPr algn="ctr" indent="0" marL="0">
+              <a:buNone/>
+            </a:pPr>
+            <a:r>
+              <a:rPr lang="en-US" sz="1200" dirty="0">
+                <a:solidFill>
+                  <a:schemeClr val="bg1"/>
+                </a:solidFill>
+              </a:rPr>
+              <a:t>504 clean records, labels instead of IDs</a:t>
+            </a:r>
+            <a:endParaRPr lang="en-US" sz="1700" dirty="0"/>
+          </a:p>
+        </p:txBody>
+      </p:sp>
+      <p:sp>
+        <p:nvSpPr>
+          <p:cNvPr id="39" name="Not used label"/>
+          <p:cNvSpPr txBox="1"/>
+          <p:nvPr/>
+        </p:nvSpPr>
+        <p:spPr>
+          <a:xfrm>
+            <a:off x="548640" y="5440680"/>
+            <a:ext cx="1280160" cy="548640"/>
+          </a:xfrm>
+          <a:prstGeom prst="rect">
+            <a:avLst/>
+          </a:prstGeom>
+          <a:noFill/>
+          <a:ln/>
+        </p:spPr>
+        <p:txBody>
+          <a:bodyPr wrap="square" lIns="0" tIns="0" rIns="0" bIns="0" rtlCol="0" anchor="ctr"/>
+          <a:lstStyle/>
+          <a:p>
+            <a:pPr indent="0" marL="0">
+              <a:buNone/>
+            </a:pPr>
+            <a:r>
+              <a:rPr lang="en-US" sz="1400" b="1" dirty="0">
+                <a:solidFill>
+                  <a:schemeClr val="accent6"/>
+                </a:solidFill>
+              </a:rPr>
+              <a:t>Not used</a:t>
+            </a:r>
+            <a:endParaRPr lang="en-US" sz="1400" dirty="0"/>
+          </a:p>
+        </p:txBody>
+      </p:sp>
+      <p:sp>
+        <p:nvSpPr>
+          <p:cNvPr id="40" name="Unused domaines.csv"/>
+          <p:cNvSpPr/>
+          <p:nvPr/>
+        </p:nvSpPr>
+        <p:spPr>
+          <a:xfrm>
+            <a:off x="1828800" y="5440680"/>
+            <a:ext cx="4709160" cy="548640"/>
+          </a:xfrm>
+          <a:prstGeom prst="roundRect">
+            <a:avLst>
+              <a:gd name="adj" fmla="val 16667"/>
+            </a:avLst>
+          </a:prstGeom>
+          <a:solidFill>
+            <a:schemeClr val="bg1"/>
+          </a:solidFill>
+          <a:ln w="15875">
+            <a:solidFill>
+              <a:schemeClr val="accent4"/>
+            </a:solidFill>
+            <a:prstDash val="dash"/>
+          </a:ln>
+        </p:spPr>
+      </p:sp>
+      <p:sp>
+        <p:nvSpPr>
+          <p:cNvPr id="41" name="Unused text domaines.csv"/>
+          <p:cNvSpPr txBox="1"/>
+          <p:nvPr/>
+        </p:nvSpPr>
+        <p:spPr>
+          <a:xfrm>
+            <a:off x="2011680" y="5440680"/>
+            <a:ext cx="4389120" cy="548640"/>
+          </a:xfrm>
+          <a:prstGeom prst="rect">
+            <a:avLst/>
+          </a:prstGeom>
+          <a:noFill/>
+          <a:ln/>
+        </p:spPr>
+        <p:txBody>
+          <a:bodyPr wrap="square" lIns="0" tIns="0" rIns="0" bIns="0" rtlCol="0" anchor="ctr"/>
+          <a:lstStyle/>
+          <a:p>
+            <a:pPr indent="0" marL="0">
+              <a:buNone/>
+            </a:pPr>
+            <a:r>
+              <a:rPr lang="en-US" sz="1300" b="1" dirty="0">
+                <a:solidFill>
+                  <a:schemeClr val="tx2"/>
+                </a:solidFill>
+              </a:rPr>
+              <a:t>domaines.csv  </a:t>
+            </a:r>
+            <a:pPr indent="0" marL="0">
+              <a:buNone/>
+            </a:pPr>
+            <a:r>
+              <a:rPr lang="en-US" sz="1300" dirty="0">
+                <a:solidFill>
+                  <a:schemeClr val="accent6"/>
+                </a:solidFill>
+              </a:rPr>
+              <a:t>domain names already written in aides.csv</a:t>
+            </a:r>
+            <a:endParaRPr lang="en-US" sz="1300" dirty="0"/>
+          </a:p>
+        </p:txBody>
+      </p:sp>
+      <p:sp>
+        <p:nvSpPr>
+          <p:cNvPr id="42" name="Unused niveaux.csv"/>
+          <p:cNvSpPr/>
+          <p:nvPr/>
+        </p:nvSpPr>
+        <p:spPr>
+          <a:xfrm>
+            <a:off x="6812280" y="5440680"/>
+            <a:ext cx="4709160" cy="548640"/>
+          </a:xfrm>
+          <a:prstGeom prst="roundRect">
+            <a:avLst>
+              <a:gd name="adj" fmla="val 16667"/>
+            </a:avLst>
+          </a:prstGeom>
+          <a:solidFill>
+            <a:schemeClr val="bg1"/>
+          </a:solidFill>
+          <a:ln w="15875">
+            <a:solidFill>
+              <a:schemeClr val="accent4"/>
+            </a:solidFill>
+            <a:prstDash val="dash"/>
+          </a:ln>
+        </p:spPr>
+      </p:sp>
+      <p:sp>
+        <p:nvSpPr>
+          <p:cNvPr id="43" name="Unused text niveaux.csv"/>
+          <p:cNvSpPr txBox="1"/>
+          <p:nvPr/>
+        </p:nvSpPr>
+        <p:spPr>
+          <a:xfrm>
+            <a:off x="6995160" y="5440680"/>
+            <a:ext cx="4389120" cy="548640"/>
+          </a:xfrm>
+          <a:prstGeom prst="rect">
+            <a:avLst/>
+          </a:prstGeom>
+          <a:noFill/>
+          <a:ln/>
+        </p:spPr>
+        <p:txBody>
+          <a:bodyPr wrap="square" lIns="0" tIns="0" rIns="0" bIns="0" rtlCol="0" anchor="ctr"/>
+          <a:lstStyle/>
+          <a:p>
+            <a:pPr indent="0" marL="0">
+              <a:buNone/>
+            </a:pPr>
+            <a:r>
+              <a:rPr lang="en-US" sz="1300" b="1" dirty="0">
+                <a:solidFill>
+                  <a:schemeClr val="tx2"/>
+                </a:solidFill>
+              </a:rPr>
+              <a:t>niveaux.csv  </a:t>
+            </a:r>
+            <a:pPr indent="0" marL="0">
+              <a:buNone/>
+            </a:pPr>
+            <a:r>
+              <a:rPr lang="en-US" sz="1300" dirty="0">
+                <a:solidFill>
+                  <a:schemeClr val="accent6"/>
+                </a:solidFill>
+              </a:rPr>
+              <a:t>national / regional / EU level already in aides.csv</a:t>
+            </a:r>
+            <a:endParaRPr lang="en-US" sz="1300" dirty="0"/>
+          </a:p>
+        </p:txBody>
+      </p:sp>
+      <p:sp>
+        <p:nvSpPr>
+          <p:cNvPr id="44" name="Footnote 3"/>
+          <p:cNvSpPr txBox="1"/>
+          <p:nvPr/>
+        </p:nvSpPr>
+        <p:spPr>
+          <a:xfrm>
+            <a:off x="548640" y="6355080"/>
+            <a:ext cx="11064240" cy="274320"/>
+          </a:xfrm>
+          <a:prstGeom prst="rect">
+            <a:avLst/>
+          </a:prstGeom>
+          <a:noFill/>
+          <a:ln/>
+        </p:spPr>
+        <p:txBody>
+          <a:bodyPr wrap="square" lIns="0" tIns="0" rIns="0" bIns="0" rtlCol="0" anchor="ctr"/>
+          <a:lstStyle/>
+          <a:p>
+            <a:pPr indent="0" marL="0">
+              <a:buNone/>
+            </a:pPr>
+            <a:r>
+              <a:rPr lang="en-US" sz="1000" dirty="0">
+                <a:solidFill>
+                  <a:schemeClr val="accent6"/>
+                </a:solidFill>
+              </a:rPr>
+              <a:t>Joins are made on IDs (e.g. aides.natures → natures.id_typ). Counts are from data/processed/aids.jsonl, checked 14 Oct 2026. No external dataset was merged.</a:t>
             </a:r>
             <a:endParaRPr lang="en-US" sz="1000" dirty="0"/>
           </a:p>

</xml_diff>